<commit_message>
Add 1,000-sample distribution chart to Agent slide
Co-Authored-By: Claude Opus 5.5 <noreply@anthropic.com>
Claude-Session: https://claude.ai/code/session_011iFrL2Hfizgp6kYckDtNGc
</commit_message>
<xml_diff>
--- a/火车票Agent页.pptx
+++ b/火车票Agent页.pptx
@@ -125,6 +125,242 @@
     </p:extLst>
   </p:cmAuthor>
 </p:cmAuthorLst>
+</file>
+
+<file path=ppt/charts/chart1.xml><?xml version="1.0" encoding="utf-8"?>
+<c:chartSpace xmlns:c="http://schemas.openxmlformats.org/drawingml/2006/chart" xmlns:a="http://schemas.openxmlformats.org/drawingml/2006/main" xmlns:r="http://schemas.openxmlformats.org/officeDocument/2006/relationships">
+  <c:date1904 val="0"/>
+  <c:chart>
+    <c:autoTitleDeleted val="1"/>
+    <c:plotArea>
+      <c:barChart>
+        <c:barDir val="bar"/>
+        <c:grouping val="stacked"/>
+        <c:ser>
+          <c:idx val="0"/>
+          <c:order val="0"/>
+          <c:tx>
+            <c:strRef>
+              <c:f>Sheet1!$B$1</c:f>
+              <c:strCache>
+                <c:ptCount val="1"/>
+                <c:pt idx="0">
+                  <c:v>一致</c:v>
+                </c:pt>
+              </c:strCache>
+            </c:strRef>
+          </c:tx>
+          <c:spPr>
+            <a:solidFill>
+              <a:srgbClr val="C9DCF8"/>
+            </a:solidFill>
+          </c:spPr>
+          <c:cat>
+            <c:strRef>
+              <c:f>Sheet1!$A$2:$A$2</c:f>
+              <c:strCache>
+                <c:ptCount val="1"/>
+                <c:pt idx="0">
+                  <c:v>样本</c:v>
+                </c:pt>
+              </c:strCache>
+            </c:strRef>
+          </c:cat>
+          <c:val>
+            <c:numRef>
+              <c:f>Sheet1!$B$2:$B$2</c:f>
+              <c:numCache>
+                <c:formatCode>General</c:formatCode>
+                <c:ptCount val="1"/>
+                <c:pt idx="0">
+                  <c:v>749</c:v>
+                </c:pt>
+              </c:numCache>
+            </c:numRef>
+          </c:val>
+        </c:ser>
+        <c:ser>
+          <c:idx val="1"/>
+          <c:order val="1"/>
+          <c:tx>
+            <c:strRef>
+              <c:f>Sheet1!$C$1</c:f>
+              <c:strCache>
+                <c:ptCount val="1"/>
+                <c:pt idx="0">
+                  <c:v>Agent 对</c:v>
+                </c:pt>
+              </c:strCache>
+            </c:strRef>
+          </c:tx>
+          <c:spPr>
+            <a:solidFill>
+              <a:srgbClr val="8DB8F5"/>
+            </a:solidFill>
+          </c:spPr>
+          <c:cat>
+            <c:strRef>
+              <c:f>Sheet1!$A$2:$A$2</c:f>
+              <c:strCache>
+                <c:ptCount val="1"/>
+                <c:pt idx="0">
+                  <c:v>样本</c:v>
+                </c:pt>
+              </c:strCache>
+            </c:strRef>
+          </c:cat>
+          <c:val>
+            <c:numRef>
+              <c:f>Sheet1!$C$2:$C$2</c:f>
+              <c:numCache>
+                <c:formatCode>General</c:formatCode>
+                <c:ptCount val="1"/>
+                <c:pt idx="0">
+                  <c:v>197</c:v>
+                </c:pt>
+              </c:numCache>
+            </c:numRef>
+          </c:val>
+        </c:ser>
+        <c:ser>
+          <c:idx val="2"/>
+          <c:order val="2"/>
+          <c:tx>
+            <c:strRef>
+              <c:f>Sheet1!$D$1</c:f>
+              <c:strCache>
+                <c:ptCount val="1"/>
+                <c:pt idx="0">
+                  <c:v>算法对、Agent 错</c:v>
+                </c:pt>
+              </c:strCache>
+            </c:strRef>
+          </c:tx>
+          <c:spPr>
+            <a:solidFill>
+              <a:srgbClr val="FF7A1A"/>
+            </a:solidFill>
+          </c:spPr>
+          <c:cat>
+            <c:strRef>
+              <c:f>Sheet1!$A$2:$A$2</c:f>
+              <c:strCache>
+                <c:ptCount val="1"/>
+                <c:pt idx="0">
+                  <c:v>样本</c:v>
+                </c:pt>
+              </c:strCache>
+            </c:strRef>
+          </c:cat>
+          <c:val>
+            <c:numRef>
+              <c:f>Sheet1!$D$2:$D$2</c:f>
+              <c:numCache>
+                <c:formatCode>General</c:formatCode>
+                <c:ptCount val="1"/>
+                <c:pt idx="0">
+                  <c:v>21</c:v>
+                </c:pt>
+              </c:numCache>
+            </c:numRef>
+          </c:val>
+        </c:ser>
+        <c:ser>
+          <c:idx val="3"/>
+          <c:order val="3"/>
+          <c:tx>
+            <c:strRef>
+              <c:f>Sheet1!$E$1</c:f>
+              <c:strCache>
+                <c:ptCount val="1"/>
+                <c:pt idx="0">
+                  <c:v>都错</c:v>
+                </c:pt>
+              </c:strCache>
+            </c:strRef>
+          </c:tx>
+          <c:spPr>
+            <a:solidFill>
+              <a:srgbClr val="7A8599"/>
+            </a:solidFill>
+          </c:spPr>
+          <c:cat>
+            <c:strRef>
+              <c:f>Sheet1!$A$2:$A$2</c:f>
+              <c:strCache>
+                <c:ptCount val="1"/>
+                <c:pt idx="0">
+                  <c:v>样本</c:v>
+                </c:pt>
+              </c:strCache>
+            </c:strRef>
+          </c:cat>
+          <c:val>
+            <c:numRef>
+              <c:f>Sheet1!$E$2:$E$2</c:f>
+              <c:numCache>
+                <c:formatCode>General</c:formatCode>
+                <c:ptCount val="1"/>
+                <c:pt idx="0">
+                  <c:v>33</c:v>
+                </c:pt>
+              </c:numCache>
+            </c:numRef>
+          </c:val>
+        </c:ser>
+        <c:gapWidth val="0"/>
+        <c:overlap val="100"/>
+        <c:axId val="-2068027336"/>
+        <c:axId val="-2113994440"/>
+      </c:barChart>
+      <c:catAx>
+        <c:axId val="-2068027336"/>
+        <c:scaling>
+          <c:orientation val="minMax"/>
+        </c:scaling>
+        <c:delete/>
+        <c:axPos val="l"/>
+        <c:majorTickMark val="out"/>
+        <c:minorTickMark val="none"/>
+        <c:tickLblPos val="nextTo"/>
+        <c:crossAx val="-2113994440"/>
+        <c:crosses val="autoZero"/>
+        <c:auto val="1"/>
+        <c:lblAlgn val="ctr"/>
+        <c:lblOffset val="100"/>
+        <c:noMultiLvlLbl val="0"/>
+      </c:catAx>
+      <c:valAx>
+        <c:axId val="-2113994440"/>
+        <c:scaling>
+          <c:max val="1000.0"/>
+          <c:min val="0.0"/>
+        </c:scaling>
+        <c:delete/>
+        <c:axPos val="b"/>
+        <c:majorTickMark val="out"/>
+        <c:minorTickMark val="none"/>
+        <c:tickLblPos val="nextTo"/>
+        <c:crossAx val="-2068027336"/>
+        <c:crosses val="autoZero"/>
+      </c:valAx>
+    </c:plotArea>
+    <c:dispBlanksAs val="gap"/>
+  </c:chart>
+  <c:txPr>
+    <a:bodyPr/>
+    <a:lstStyle/>
+    <a:p>
+      <a:pPr>
+        <a:defRPr sz="1800"/>
+      </a:pPr>
+      <a:endParaRPr lang="en-US"/>
+    </a:p>
+  </c:txPr>
+  <c:externalData r:id="rId1">
+    <c:autoUpdate val="0"/>
+  </c:externalData>
+</c:chartSpace>
 </file>
 
 <file path=ppt/notesMasters/notesMaster1.xml><?xml version="1.0" encoding="utf-8"?>
@@ -5757,7 +5993,7 @@
         </p:nvSpPr>
         <p:spPr>
           <a:xfrm>
-            <a:off x="502920" y="2176272"/>
+            <a:off x="502920" y="2148840"/>
             <a:ext cx="502920" cy="502920"/>
           </a:xfrm>
           <a:prstGeom prst="ellipse">
@@ -5807,7 +6043,7 @@
         </p:blipFill>
         <p:spPr>
           <a:xfrm>
-            <a:off x="628650" y="2302002"/>
+            <a:off x="628650" y="2274570"/>
             <a:ext cx="251460" cy="251460"/>
           </a:xfrm>
           <a:prstGeom prst="rect">
@@ -5823,7 +6059,7 @@
         </p:nvSpPr>
         <p:spPr>
           <a:xfrm>
-            <a:off x="1188720" y="2157984"/>
+            <a:off x="1188720" y="2130552"/>
             <a:ext cx="4709160" cy="329184"/>
           </a:xfrm>
           <a:prstGeom prst="rect">
@@ -5860,8 +6096,8 @@
         </p:nvSpPr>
         <p:spPr>
           <a:xfrm>
-            <a:off x="1188720" y="2523744"/>
-            <a:ext cx="4709160" cy="731520"/>
+            <a:off x="1188720" y="2478024"/>
+            <a:ext cx="4709160" cy="640080"/>
           </a:xfrm>
           <a:prstGeom prst="rect">
             <a:avLst/>
@@ -5901,7 +6137,7 @@
           <a:p>
             <a:pPr algn="l">
               <a:spcBef>
-                <a:spcPts val="400"/>
+                <a:spcPts val="300"/>
               </a:spcBef>
             </a:pPr>
             <a:r>
@@ -5937,7 +6173,7 @@
         </p:nvSpPr>
         <p:spPr>
           <a:xfrm>
-            <a:off x="502920" y="3364991"/>
+            <a:off x="502920" y="3200400"/>
             <a:ext cx="502920" cy="502920"/>
           </a:xfrm>
           <a:prstGeom prst="ellipse">
@@ -5987,7 +6223,7 @@
         </p:blipFill>
         <p:spPr>
           <a:xfrm>
-            <a:off x="628650" y="3490722"/>
+            <a:off x="628650" y="3326130"/>
             <a:ext cx="251460" cy="251460"/>
           </a:xfrm>
           <a:prstGeom prst="rect">
@@ -6003,7 +6239,7 @@
         </p:nvSpPr>
         <p:spPr>
           <a:xfrm>
-            <a:off x="1188720" y="3346703"/>
+            <a:off x="1188720" y="3182112"/>
             <a:ext cx="4709160" cy="329184"/>
           </a:xfrm>
           <a:prstGeom prst="rect">
@@ -6040,8 +6276,8 @@
         </p:nvSpPr>
         <p:spPr>
           <a:xfrm>
-            <a:off x="1188720" y="3712463"/>
-            <a:ext cx="4709160" cy="731520"/>
+            <a:off x="1188720" y="3529584"/>
+            <a:ext cx="4709160" cy="640080"/>
           </a:xfrm>
           <a:prstGeom prst="rect">
             <a:avLst/>
@@ -6078,35 +6314,6 @@
               <a:t>抽样 1,000 条线上 query，与算法业务标签逐条比对</a:t>
             </a:r>
           </a:p>
-          <a:p>
-            <a:pPr algn="l">
-              <a:spcBef>
-                <a:spcPts val="400"/>
-              </a:spcBef>
-            </a:pPr>
-            <a:r>
-              <a:rPr sz="900" b="0">
-                <a:solidFill>
-                  <a:srgbClr val="287DFA"/>
-                </a:solidFill>
-                <a:latin typeface="微软雅黑"/>
-                <a:ea typeface="微软雅黑"/>
-                <a:cs typeface="微软雅黑"/>
-              </a:rPr>
-              <a:t>●  </a:t>
-            </a:r>
-            <a:r>
-              <a:rPr sz="1300" b="0">
-                <a:solidFill>
-                  <a:srgbClr val="3D4757"/>
-                </a:solidFill>
-                <a:latin typeface="微软雅黑"/>
-                <a:ea typeface="微软雅黑"/>
-                <a:cs typeface="微软雅黑"/>
-              </a:rPr>
-              <a:t>针对“算法正确、Agent 错误”的样本，逐类修订分类标准</a:t>
-            </a:r>
-          </a:p>
         </p:txBody>
       </p:sp>
       <p:sp>
@@ -6117,8 +6324,8 @@
         </p:nvSpPr>
         <p:spPr>
           <a:xfrm>
-            <a:off x="457200" y="4572000"/>
-            <a:ext cx="5486400" cy="1508760"/>
+            <a:off x="457200" y="4617720"/>
+            <a:ext cx="5486400" cy="1463040"/>
           </a:xfrm>
           <a:prstGeom prst="roundRect">
             <a:avLst>
@@ -6161,7 +6368,7 @@
         </p:nvSpPr>
         <p:spPr>
           <a:xfrm>
-            <a:off x="731520" y="4663440"/>
+            <a:off x="731520" y="4690872"/>
             <a:ext cx="1828800" cy="274320"/>
           </a:xfrm>
           <a:prstGeom prst="rect">
@@ -6355,7 +6562,7 @@
         </p:nvSpPr>
         <p:spPr>
           <a:xfrm>
-            <a:off x="731520" y="5513832"/>
+            <a:off x="731520" y="5495544"/>
             <a:ext cx="2194560" cy="457200"/>
           </a:xfrm>
           <a:prstGeom prst="rect">
@@ -6392,7 +6599,7 @@
         </p:nvSpPr>
         <p:spPr>
           <a:xfrm>
-            <a:off x="2926080" y="5513832"/>
+            <a:off x="2926080" y="5495544"/>
             <a:ext cx="1965960" cy="457200"/>
           </a:xfrm>
           <a:prstGeom prst="rect">
@@ -6429,7 +6636,7 @@
         </p:nvSpPr>
         <p:spPr>
           <a:xfrm>
-            <a:off x="4864608" y="5586984"/>
+            <a:off x="4864608" y="5568696"/>
             <a:ext cx="1005840" cy="310896"/>
           </a:xfrm>
           <a:prstGeom prst="roundRect">
@@ -6475,7 +6682,7 @@
         </p:nvSpPr>
         <p:spPr>
           <a:xfrm>
-            <a:off x="4864608" y="5586984"/>
+            <a:off x="4864608" y="5568696"/>
             <a:ext cx="1005840" cy="310896"/>
           </a:xfrm>
           <a:prstGeom prst="rect">
@@ -6593,7 +6800,7 @@
         </p:nvSpPr>
         <p:spPr>
           <a:xfrm>
-            <a:off x="6291072" y="2176272"/>
+            <a:off x="6291072" y="2148840"/>
             <a:ext cx="502920" cy="502920"/>
           </a:xfrm>
           <a:prstGeom prst="ellipse">
@@ -6643,7 +6850,7 @@
         </p:blipFill>
         <p:spPr>
           <a:xfrm>
-            <a:off x="6416802" y="2302002"/>
+            <a:off x="6416802" y="2274570"/>
             <a:ext cx="251460" cy="251460"/>
           </a:xfrm>
           <a:prstGeom prst="rect">
@@ -6659,7 +6866,7 @@
         </p:nvSpPr>
         <p:spPr>
           <a:xfrm>
-            <a:off x="6976872" y="2157984"/>
+            <a:off x="6976872" y="2130552"/>
             <a:ext cx="4709160" cy="329184"/>
           </a:xfrm>
           <a:prstGeom prst="rect">
@@ -6696,8 +6903,8 @@
         </p:nvSpPr>
         <p:spPr>
           <a:xfrm>
-            <a:off x="6976872" y="2523744"/>
-            <a:ext cx="4709160" cy="731520"/>
+            <a:off x="6976872" y="2478024"/>
+            <a:ext cx="4709160" cy="640080"/>
           </a:xfrm>
           <a:prstGeom prst="rect">
             <a:avLst/>
@@ -6737,7 +6944,7 @@
           <a:p>
             <a:pPr algn="l">
               <a:spcBef>
-                <a:spcPts val="400"/>
+                <a:spcPts val="300"/>
               </a:spcBef>
             </a:pPr>
             <a:r>
@@ -6773,7 +6980,7 @@
         </p:nvSpPr>
         <p:spPr>
           <a:xfrm>
-            <a:off x="6291072" y="3364991"/>
+            <a:off x="6291072" y="3200400"/>
             <a:ext cx="502920" cy="502920"/>
           </a:xfrm>
           <a:prstGeom prst="ellipse">
@@ -6823,7 +7030,7 @@
         </p:blipFill>
         <p:spPr>
           <a:xfrm>
-            <a:off x="6416802" y="3490722"/>
+            <a:off x="6416802" y="3326130"/>
             <a:ext cx="251460" cy="251460"/>
           </a:xfrm>
           <a:prstGeom prst="rect">
@@ -6839,7 +7046,7 @@
         </p:nvSpPr>
         <p:spPr>
           <a:xfrm>
-            <a:off x="6976872" y="3346703"/>
+            <a:off x="6976872" y="3182112"/>
             <a:ext cx="4709160" cy="329184"/>
           </a:xfrm>
           <a:prstGeom prst="rect">
@@ -6876,8 +7083,8 @@
         </p:nvSpPr>
         <p:spPr>
           <a:xfrm>
-            <a:off x="6976872" y="3712463"/>
-            <a:ext cx="4709160" cy="731520"/>
+            <a:off x="6976872" y="3529584"/>
+            <a:ext cx="4709160" cy="640080"/>
           </a:xfrm>
           <a:prstGeom prst="rect">
             <a:avLst/>
@@ -6917,7 +7124,7 @@
           <a:p>
             <a:pPr algn="l">
               <a:spcBef>
-                <a:spcPts val="400"/>
+                <a:spcPts val="300"/>
               </a:spcBef>
             </a:pPr>
             <a:r>
@@ -6953,8 +7160,8 @@
         </p:nvSpPr>
         <p:spPr>
           <a:xfrm>
-            <a:off x="6245352" y="4572000"/>
-            <a:ext cx="5486400" cy="1508760"/>
+            <a:off x="6245352" y="4617720"/>
+            <a:ext cx="5486400" cy="1463040"/>
           </a:xfrm>
           <a:prstGeom prst="roundRect">
             <a:avLst>
@@ -6997,7 +7204,7 @@
         </p:nvSpPr>
         <p:spPr>
           <a:xfrm>
-            <a:off x="6519672" y="4663440"/>
+            <a:off x="6519672" y="4690872"/>
             <a:ext cx="1828800" cy="274320"/>
           </a:xfrm>
           <a:prstGeom prst="rect">
@@ -7179,6 +7386,138 @@
                 <a:cs typeface="微软雅黑"/>
               </a:rPr>
               <a:t>lift −54.2%</a:t>
+            </a:r>
+          </a:p>
+        </p:txBody>
+      </p:sp>
+      <p:graphicFrame>
+        <p:nvGraphicFramePr>
+          <p:cNvPr id="40" name="1000条样本分布"/>
+          <p:cNvGraphicFramePr>
+            <a:graphicFrameLocks noGrp="1"/>
+          </p:cNvGraphicFramePr>
+          <p:nvPr/>
+        </p:nvGraphicFramePr>
+        <p:xfrm>
+          <a:off x="1143000" y="3822191"/>
+          <a:ext cx="4343400" cy="384048"/>
+        </p:xfrm>
+        <a:graphic>
+          <a:graphicData uri="http://schemas.openxmlformats.org/drawingml/2006/chart">
+            <c:chart xmlns:c="http://schemas.openxmlformats.org/drawingml/2006/chart" r:id="rId6"/>
+          </a:graphicData>
+        </a:graphic>
+      </p:graphicFrame>
+      <p:sp>
+        <p:nvSpPr>
+          <p:cNvPr id="41" name="TextBox 40"/>
+          <p:cNvSpPr txBox="1"/>
+          <p:nvPr/>
+        </p:nvSpPr>
+        <p:spPr>
+          <a:xfrm>
+            <a:off x="1188720" y="4242816"/>
+            <a:ext cx="4754880" cy="274320"/>
+          </a:xfrm>
+          <a:prstGeom prst="rect">
+            <a:avLst/>
+          </a:prstGeom>
+          <a:noFill/>
+        </p:spPr>
+        <p:txBody>
+          <a:bodyPr wrap="square" lIns="0" rIns="0" tIns="0" bIns="0" anchor="t">
+            <a:spAutoFit/>
+          </a:bodyPr>
+          <a:lstStyle/>
+          <a:p>
+            <a:pPr algn="l"/>
+            <a:r>
+              <a:rPr sz="1000" b="0">
+                <a:solidFill>
+                  <a:srgbClr val="9DBCE8"/>
+                </a:solidFill>
+                <a:latin typeface="微软雅黑"/>
+                <a:ea typeface="微软雅黑"/>
+                <a:cs typeface="微软雅黑"/>
+              </a:rPr>
+              <a:t>■ </a:t>
+            </a:r>
+            <a:r>
+              <a:rPr sz="1000" b="0">
+                <a:solidFill>
+                  <a:srgbClr val="3D4757"/>
+                </a:solidFill>
+                <a:latin typeface="微软雅黑"/>
+                <a:ea typeface="微软雅黑"/>
+                <a:cs typeface="微软雅黑"/>
+              </a:rPr>
+              <a:t>一致 749  </a:t>
+            </a:r>
+            <a:r>
+              <a:rPr sz="1000" b="0">
+                <a:solidFill>
+                  <a:srgbClr val="8DB8F5"/>
+                </a:solidFill>
+                <a:latin typeface="微软雅黑"/>
+                <a:ea typeface="微软雅黑"/>
+                <a:cs typeface="微软雅黑"/>
+              </a:rPr>
+              <a:t>■ </a:t>
+            </a:r>
+            <a:r>
+              <a:rPr sz="1000" b="0">
+                <a:solidFill>
+                  <a:srgbClr val="3D4757"/>
+                </a:solidFill>
+                <a:latin typeface="微软雅黑"/>
+                <a:ea typeface="微软雅黑"/>
+                <a:cs typeface="微软雅黑"/>
+              </a:rPr>
+              <a:t>Agent 对 197  </a:t>
+            </a:r>
+            <a:r>
+              <a:rPr sz="1000" b="0">
+                <a:solidFill>
+                  <a:srgbClr val="FF7A1A"/>
+                </a:solidFill>
+                <a:latin typeface="微软雅黑"/>
+                <a:ea typeface="微软雅黑"/>
+                <a:cs typeface="微软雅黑"/>
+              </a:rPr>
+              <a:t>■ </a:t>
+            </a:r>
+            <a:r>
+              <a:rPr sz="1000" b="1">
+                <a:solidFill>
+                  <a:srgbClr val="FF7A1A"/>
+                </a:solidFill>
+                <a:latin typeface="微软雅黑"/>
+                <a:ea typeface="微软雅黑"/>
+                <a:cs typeface="微软雅黑"/>
+              </a:rPr>
+              <a:t>算法对、Agent 错 21  </a:t>
+            </a:r>
+            <a:r>
+              <a:rPr sz="1000" b="0">
+                <a:solidFill>
+                  <a:srgbClr val="7A8599"/>
+                </a:solidFill>
+                <a:latin typeface="微软雅黑"/>
+                <a:ea typeface="微软雅黑"/>
+                <a:cs typeface="微软雅黑"/>
+              </a:rPr>
+              <a:t>■ </a:t>
+            </a:r>
+            <a:r>
+              <a:rPr sz="1000" b="0">
+                <a:solidFill>
+                  <a:srgbClr val="3D4757"/>
+                </a:solidFill>
+                <a:latin typeface="微软雅黑"/>
+                <a:ea typeface="微软雅黑"/>
+                <a:cs typeface="微软雅黑"/>
+              </a:rPr>
+              <a:t>都错 33  </a:t>
             </a:r>
           </a:p>
         </p:txBody>

</xml_diff>